<commit_message>
docs(ui): refresh dark workbench evidence
</commit_message>
<xml_diff>
--- a/deliverables/DebugMate-V0.1.pptx
+++ b/deliverables/DebugMate-V0.1.pptx
@@ -3531,8 +3531,8 @@
         </p:blipFill>
         <p:spPr>
           <a:xfrm>
-            <a:off x="502920" y="1720072"/>
-            <a:ext cx="5440680" cy="3692174"/>
+            <a:off x="502920" y="2162177"/>
+            <a:ext cx="5440680" cy="2807964"/>
           </a:xfrm>
           <a:prstGeom prst="rect">
             <a:avLst/>
@@ -3555,8 +3555,8 @@
         </p:blipFill>
         <p:spPr>
           <a:xfrm>
-            <a:off x="6245352" y="1720072"/>
-            <a:ext cx="5440680" cy="3692174"/>
+            <a:off x="6245352" y="2162177"/>
+            <a:ext cx="5440680" cy="2807964"/>
           </a:xfrm>
           <a:prstGeom prst="rect">
             <a:avLst/>
@@ -11725,8 +11725,8 @@
         </p:blipFill>
         <p:spPr>
           <a:xfrm>
-            <a:off x="689521" y="1051560"/>
-            <a:ext cx="7262037" cy="5257800"/>
+            <a:off x="594360" y="1961943"/>
+            <a:ext cx="7452360" cy="3437032"/>
           </a:xfrm>
           <a:prstGeom prst="rect">
             <a:avLst/>

</xml_diff>